<commit_message>
Tests-and-failures deck: sheets 15-16, Oct 24 pre-drive diagnostic of displays and radios
Display sheet carries a graph parsed from the two archived serial logs
(phantom separation from indoor GPS fixes) and the link-health findings;
radio sheet carries the full config/battery/GPS/last-heard check with the
two corrections applied. New Mexico placeholder is now sheet 17 of 18.

Co-Authored-By: Claude Fable 5.1 <noreply@anthropic.com>
</commit_message>
<xml_diff>
--- a/docs/presentations/Group9_TestsAndFailures.pptx
+++ b/docs/presentations/Group9_TestsAndFailures.pptx
@@ -21,6 +21,8 @@
     <p:sldId id="269" r:id="rId21"/>
     <p:sldId id="270" r:id="rId22"/>
     <p:sldId id="271" r:id="rId23"/>
+    <p:sldId id="272" r:id="rId24"/>
+    <p:sldId id="273" r:id="rId25"/>
   </p:sldIdLst>
   <p:sldSz cx="12191695" cy="6858000" type="screen4x3"/>
   <p:notesSz cx="6858000" cy="9144000"/>
@@ -937,7 +939,7 @@
           <a:lstStyle/>
           <a:p>
             <a:r>
-              <a:t>Reserved sheet. Fill the right-hand column from the screen footage when the drive is done; the pre-test audit row is already true.</a:t>
+              <a:t>This is the display track's own verification record: the links and the firmware were fine; the data they rendered was bad because the radios' GPS receivers were indoors. The graph is parsed straight from the archived serial logs.</a:t>
             </a:r>
           </a:p>
         </p:txBody>
@@ -963,6 +965,146 @@
 </file>
 
 <file path=ppt/notesSlides/notesSlide16.xml><?xml version="1.0" encoding="utf-8"?>
+<p:notes xmlns:a="http://schemas.openxmlformats.org/drawingml/2006/main" xmlns:p="http://schemas.openxmlformats.org/presentationml/2006/main" xmlns:r="http://schemas.openxmlformats.org/officeDocument/2006/relationships">
+  <p:cSld>
+    <p:spTree>
+      <p:nvGrpSpPr>
+        <p:cNvPr id="1" name=""/>
+        <p:cNvGrpSpPr/>
+        <p:nvPr/>
+      </p:nvGrpSpPr>
+      <p:grpSpPr>
+        <a:xfrm>
+          <a:off x="0" y="0"/>
+          <a:ext cx="0" cy="0"/>
+          <a:chOff x="0" y="0"/>
+          <a:chExt cx="0" cy="0"/>
+        </a:xfrm>
+      </p:grpSpPr>
+      <p:sp>
+        <p:nvSpPr>
+          <p:cNvPr id="2" name="Slide Image Placeholder 1"/>
+          <p:cNvSpPr>
+            <a:spLocks noGrp="1"/>
+          </p:cNvSpPr>
+          <p:nvPr>
+            <p:ph type="sldImg" idx="2"/>
+          </p:nvPr>
+        </p:nvSpPr>
+        <p:spPr/>
+      </p:sp>
+      <p:sp>
+        <p:nvSpPr>
+          <p:cNvPr id="3" name="Notes Placeholder 2"/>
+          <p:cNvSpPr>
+            <a:spLocks noGrp="1"/>
+          </p:cNvSpPr>
+          <p:nvPr>
+            <p:ph type="body" idx="3" sz="quarter"/>
+          </p:nvPr>
+        </p:nvSpPr>
+        <p:spPr/>
+        <p:txBody>
+          <a:bodyPr/>
+          <a:lstStyle/>
+          <a:p>
+            <a:r>
+              <a:t>Same diagnostic as the morning's, run on both radios at 14:27 before the New Mexico drive. Two leftovers corrected and read back.</a:t>
+            </a:r>
+          </a:p>
+        </p:txBody>
+      </p:sp>
+      <p:sp>
+        <p:nvSpPr>
+          <p:cNvPr id="4" name="Slide Number Placeholder 3"/>
+          <p:cNvSpPr>
+            <a:spLocks noGrp="1"/>
+          </p:cNvSpPr>
+          <p:nvPr>
+            <p:ph type="sldNum" idx="5" sz="quarter"/>
+          </p:nvPr>
+        </p:nvSpPr>
+        <p:spPr/>
+      </p:sp>
+    </p:spTree>
+  </p:cSld>
+  <p:clrMapOvr>
+    <a:masterClrMapping/>
+  </p:clrMapOvr>
+</p:notes>
+</file>
+
+<file path=ppt/notesSlides/notesSlide17.xml><?xml version="1.0" encoding="utf-8"?>
+<p:notes xmlns:a="http://schemas.openxmlformats.org/drawingml/2006/main" xmlns:p="http://schemas.openxmlformats.org/presentationml/2006/main" xmlns:r="http://schemas.openxmlformats.org/officeDocument/2006/relationships">
+  <p:cSld>
+    <p:spTree>
+      <p:nvGrpSpPr>
+        <p:cNvPr id="1" name=""/>
+        <p:cNvGrpSpPr/>
+        <p:nvPr/>
+      </p:nvGrpSpPr>
+      <p:grpSpPr>
+        <a:xfrm>
+          <a:off x="0" y="0"/>
+          <a:ext cx="0" cy="0"/>
+          <a:chOff x="0" y="0"/>
+          <a:chExt cx="0" cy="0"/>
+        </a:xfrm>
+      </p:grpSpPr>
+      <p:sp>
+        <p:nvSpPr>
+          <p:cNvPr id="2" name="Slide Image Placeholder 1"/>
+          <p:cNvSpPr>
+            <a:spLocks noGrp="1"/>
+          </p:cNvSpPr>
+          <p:nvPr>
+            <p:ph type="sldImg" idx="2"/>
+          </p:nvPr>
+        </p:nvSpPr>
+        <p:spPr/>
+      </p:sp>
+      <p:sp>
+        <p:nvSpPr>
+          <p:cNvPr id="3" name="Notes Placeholder 2"/>
+          <p:cNvSpPr>
+            <a:spLocks noGrp="1"/>
+          </p:cNvSpPr>
+          <p:nvPr>
+            <p:ph type="body" idx="3" sz="quarter"/>
+          </p:nvPr>
+        </p:nvSpPr>
+        <p:spPr/>
+        <p:txBody>
+          <a:bodyPr/>
+          <a:lstStyle/>
+          <a:p>
+            <a:r>
+              <a:t>Reserved sheet. Fill the right-hand column from the screen footage when the drive is done; the pre-test audit row is already true.</a:t>
+            </a:r>
+          </a:p>
+        </p:txBody>
+      </p:sp>
+      <p:sp>
+        <p:nvSpPr>
+          <p:cNvPr id="4" name="Slide Number Placeholder 3"/>
+          <p:cNvSpPr>
+            <a:spLocks noGrp="1"/>
+          </p:cNvSpPr>
+          <p:nvPr>
+            <p:ph type="sldNum" idx="5" sz="quarter"/>
+          </p:nvPr>
+        </p:nvSpPr>
+        <p:spPr/>
+      </p:sp>
+    </p:spTree>
+  </p:cSld>
+  <p:clrMapOvr>
+    <a:masterClrMapping/>
+  </p:clrMapOvr>
+</p:notes>
+</file>
+
+<file path=ppt/notesSlides/notesSlide18.xml><?xml version="1.0" encoding="utf-8"?>
 <p:notes xmlns:a="http://schemas.openxmlformats.org/drawingml/2006/main" xmlns:p="http://schemas.openxmlformats.org/presentationml/2006/main" xmlns:r="http://schemas.openxmlformats.org/officeDocument/2006/relationships">
   <p:cSld>
     <p:spTree>
@@ -6037,7 +6179,7 @@
                 </a:solidFill>
                 <a:latin typeface="Courier New"/>
               </a:rPr>
-              <a:t>SHEET 01/16  REV A  2026-10-24</a:t>
+              <a:t>SHEET 01/18  REV A  2026-10-24</a:t>
             </a:r>
           </a:p>
         </p:txBody>
@@ -6393,7 +6535,7 @@
                 </a:solidFill>
                 <a:latin typeface="Courier New"/>
               </a:rPr>
-              <a:t>SHEET 10/16  REV A  2026-10-24</a:t>
+              <a:t>SHEET 10/18  REV A  2026-10-24</a:t>
             </a:r>
           </a:p>
         </p:txBody>
@@ -7139,7 +7281,7 @@
                 </a:solidFill>
                 <a:latin typeface="Courier New"/>
               </a:rPr>
-              <a:t>SHEET 11/16  REV A  2026-10-24</a:t>
+              <a:t>SHEET 11/18  REV A  2026-10-24</a:t>
             </a:r>
           </a:p>
         </p:txBody>
@@ -8092,7 +8234,7 @@
                 </a:solidFill>
                 <a:latin typeface="Courier New"/>
               </a:rPr>
-              <a:t>SHEET 12/16  REV A  2026-10-24</a:t>
+              <a:t>SHEET 12/18  REV A  2026-10-24</a:t>
             </a:r>
           </a:p>
         </p:txBody>
@@ -9167,7 +9309,7 @@
                 </a:solidFill>
                 <a:latin typeface="Courier New"/>
               </a:rPr>
-              <a:t>SHEET 13/16  REV A  2026-10-24</a:t>
+              <a:t>SHEET 13/18  REV A  2026-10-24</a:t>
             </a:r>
           </a:p>
         </p:txBody>
@@ -9472,7 +9614,7 @@
                 </a:solidFill>
                 <a:latin typeface="Courier New"/>
               </a:rPr>
-              <a:t>SHEET 14/16  REV A  2026-10-24</a:t>
+              <a:t>SHEET 14/18  REV A  2026-10-24</a:t>
             </a:r>
           </a:p>
         </p:txBody>
@@ -9833,7 +9975,1665 @@
                 </a:solidFill>
                 <a:latin typeface="Courier New"/>
               </a:rPr>
-              <a:t>SHEET 15/16  REV A  2026-10-24</a:t>
+              <a:t>SHEET 15/18  REV A  2026-10-24</a:t>
+            </a:r>
+          </a:p>
+        </p:txBody>
+      </p:sp>
+      <p:sp>
+        <p:nvSpPr>
+          <p:cNvPr id="7" name="Rectangle 6"/>
+          <p:cNvSpPr/>
+          <p:nvPr/>
+        </p:nvSpPr>
+        <p:spPr>
+          <a:xfrm>
+            <a:off x="9646920" y="347472"/>
+            <a:ext cx="2148840" cy="420624"/>
+          </a:xfrm>
+          <a:prstGeom prst="rect">
+            <a:avLst/>
+          </a:prstGeom>
+          <a:solidFill>
+            <a:srgbClr val="FFFFFF"/>
+          </a:solidFill>
+          <a:ln w="19050">
+            <a:solidFill>
+              <a:srgbClr val="1199BD"/>
+            </a:solidFill>
+          </a:ln>
+          <a:effectLst/>
+        </p:spPr>
+        <p:style>
+          <a:lnRef idx="1">
+            <a:schemeClr val="accent1"/>
+          </a:lnRef>
+          <a:fillRef idx="3">
+            <a:schemeClr val="accent1"/>
+          </a:fillRef>
+          <a:effectRef idx="2">
+            <a:schemeClr val="accent1"/>
+          </a:effectRef>
+          <a:fontRef idx="minor">
+            <a:schemeClr val="lt1"/>
+          </a:fontRef>
+        </p:style>
+        <p:txBody>
+          <a:bodyPr rtlCol="0" anchor="ctr"/>
+          <a:lstStyle/>
+          <a:p>
+            <a:pPr algn="ctr"/>
+          </a:p>
+        </p:txBody>
+      </p:sp>
+      <p:sp>
+        <p:nvSpPr>
+          <p:cNvPr id="8" name="TextBox 7"/>
+          <p:cNvSpPr txBox="1"/>
+          <p:nvPr/>
+        </p:nvSpPr>
+        <p:spPr>
+          <a:xfrm>
+            <a:off x="9646920" y="402336"/>
+            <a:ext cx="2148840" cy="310896"/>
+          </a:xfrm>
+          <a:prstGeom prst="rect">
+            <a:avLst/>
+          </a:prstGeom>
+          <a:noFill/>
+        </p:spPr>
+        <p:txBody>
+          <a:bodyPr wrap="square" lIns="0" rIns="0" tIns="0" bIns="0">
+            <a:spAutoFit/>
+          </a:bodyPr>
+          <a:lstStyle/>
+          <a:p>
+            <a:pPr algn="ctr"/>
+            <a:r>
+              <a:rPr sz="1100" b="1" i="0">
+                <a:solidFill>
+                  <a:srgbClr val="1199BD"/>
+                </a:solidFill>
+                <a:latin typeface="Courier New"/>
+              </a:rPr>
+              <a:t>OWNER: DEO</a:t>
+            </a:r>
+          </a:p>
+        </p:txBody>
+      </p:sp>
+      <p:sp>
+        <p:nvSpPr>
+          <p:cNvPr id="9" name="TextBox 8"/>
+          <p:cNvSpPr txBox="1"/>
+          <p:nvPr/>
+        </p:nvSpPr>
+        <p:spPr>
+          <a:xfrm>
+            <a:off x="457200" y="329184"/>
+            <a:ext cx="9052560" cy="566928"/>
+          </a:xfrm>
+          <a:prstGeom prst="rect">
+            <a:avLst/>
+          </a:prstGeom>
+          <a:noFill/>
+        </p:spPr>
+        <p:txBody>
+          <a:bodyPr wrap="square" lIns="0" rIns="0" tIns="0" bIns="0">
+            <a:spAutoFit/>
+          </a:bodyPr>
+          <a:lstStyle/>
+          <a:p>
+            <a:pPr algn="l"/>
+            <a:r>
+              <a:rPr sz="2300" b="1" i="0" spc="200">
+                <a:solidFill>
+                  <a:srgbClr val="16213D"/>
+                </a:solidFill>
+                <a:latin typeface="Cambria"/>
+              </a:rPr>
+              <a:t>PRE-DRIVE DIAGNOSTIC, OCT 24: THE DISPLAYS</a:t>
+            </a:r>
+          </a:p>
+        </p:txBody>
+      </p:sp>
+      <p:pic>
+        <p:nvPicPr>
+          <p:cNvPr id="10" name="Picture 9" descr="g_lcddiag.png"/>
+          <p:cNvPicPr>
+            <a:picLocks noChangeAspect="1"/>
+          </p:cNvPicPr>
+          <p:nvPr/>
+        </p:nvPicPr>
+        <p:blipFill>
+          <a:blip r:embed="rId2"/>
+          <a:stretch>
+            <a:fillRect/>
+          </a:stretch>
+        </p:blipFill>
+        <p:spPr>
+          <a:xfrm>
+            <a:off x="502920" y="1143000"/>
+            <a:ext cx="7589520" cy="2815467"/>
+          </a:xfrm>
+          <a:prstGeom prst="rect">
+            <a:avLst/>
+          </a:prstGeom>
+        </p:spPr>
+      </p:pic>
+      <p:sp>
+        <p:nvSpPr>
+          <p:cNvPr id="11" name="Rectangle 10"/>
+          <p:cNvSpPr/>
+          <p:nvPr/>
+        </p:nvSpPr>
+        <p:spPr>
+          <a:xfrm>
+            <a:off x="8275320" y="1143000"/>
+            <a:ext cx="3429000" cy="2834640"/>
+          </a:xfrm>
+          <a:prstGeom prst="rect">
+            <a:avLst/>
+          </a:prstGeom>
+          <a:solidFill>
+            <a:srgbClr val="F2F5FA"/>
+          </a:solidFill>
+          <a:ln w="15875">
+            <a:solidFill>
+              <a:srgbClr val="1F9D68"/>
+            </a:solidFill>
+          </a:ln>
+          <a:effectLst/>
+        </p:spPr>
+        <p:style>
+          <a:lnRef idx="1">
+            <a:schemeClr val="accent1"/>
+          </a:lnRef>
+          <a:fillRef idx="3">
+            <a:schemeClr val="accent1"/>
+          </a:fillRef>
+          <a:effectRef idx="2">
+            <a:schemeClr val="accent1"/>
+          </a:effectRef>
+          <a:fontRef idx="minor">
+            <a:schemeClr val="lt1"/>
+          </a:fontRef>
+        </p:style>
+        <p:txBody>
+          <a:bodyPr rtlCol="0" anchor="ctr"/>
+          <a:lstStyle/>
+          <a:p>
+            <a:pPr algn="ctr"/>
+          </a:p>
+        </p:txBody>
+      </p:sp>
+      <p:sp>
+        <p:nvSpPr>
+          <p:cNvPr id="12" name="TextBox 11"/>
+          <p:cNvSpPr txBox="1"/>
+          <p:nvPr/>
+        </p:nvSpPr>
+        <p:spPr>
+          <a:xfrm>
+            <a:off x="8439912" y="1261872"/>
+            <a:ext cx="3099816" cy="2596896"/>
+          </a:xfrm>
+          <a:prstGeom prst="rect">
+            <a:avLst/>
+          </a:prstGeom>
+          <a:noFill/>
+        </p:spPr>
+        <p:txBody>
+          <a:bodyPr wrap="square" lIns="0" rIns="0" tIns="0" bIns="0">
+            <a:spAutoFit/>
+          </a:bodyPr>
+          <a:lstStyle/>
+          <a:p>
+            <a:r>
+              <a:rPr sz="1300" b="1" spc="100">
+                <a:solidFill>
+                  <a:srgbClr val="1F9D68"/>
+                </a:solidFill>
+                <a:latin typeface="Cambria"/>
+              </a:rPr>
+              <a:t>WHAT THE SERIAL LOGS PROVED</a:t>
+            </a:r>
+          </a:p>
+          <a:p>
+            <a:r>
+              <a:rPr sz="1100">
+                <a:solidFill>
+                  <a:srgbClr val="222A3F"/>
+                </a:solidFill>
+                <a:latin typeface="Cambria"/>
+              </a:rPr>
+              <a:t>Both displays booted clean, paired in under 8 s (encrypted=1 bonded=0, every config write status 0), completed the config dump, built the correct node table (SF/RG), and held the link at heartbeat state 3 with zero rescans. Display 1 again needed a USB-C plug flip before it enumerated.</a:t>
+            </a:r>
+          </a:p>
+        </p:txBody>
+      </p:sp>
+      <p:sp>
+        <p:nvSpPr>
+          <p:cNvPr id="13" name="Rectangle 12"/>
+          <p:cNvSpPr/>
+          <p:nvPr/>
+        </p:nvSpPr>
+        <p:spPr>
+          <a:xfrm>
+            <a:off x="502920" y="4160520"/>
+            <a:ext cx="11201400" cy="1600200"/>
+          </a:xfrm>
+          <a:prstGeom prst="rect">
+            <a:avLst/>
+          </a:prstGeom>
+          <a:solidFill>
+            <a:srgbClr val="F2F5FA"/>
+          </a:solidFill>
+          <a:ln w="15875">
+            <a:solidFill>
+              <a:srgbClr val="C43A4B"/>
+            </a:solidFill>
+          </a:ln>
+          <a:effectLst/>
+        </p:spPr>
+        <p:style>
+          <a:lnRef idx="1">
+            <a:schemeClr val="accent1"/>
+          </a:lnRef>
+          <a:fillRef idx="3">
+            <a:schemeClr val="accent1"/>
+          </a:fillRef>
+          <a:effectRef idx="2">
+            <a:schemeClr val="accent1"/>
+          </a:effectRef>
+          <a:fontRef idx="minor">
+            <a:schemeClr val="lt1"/>
+          </a:fontRef>
+        </p:style>
+        <p:txBody>
+          <a:bodyPr rtlCol="0" anchor="ctr"/>
+          <a:lstStyle/>
+          <a:p>
+            <a:pPr algn="ctr"/>
+          </a:p>
+        </p:txBody>
+      </p:sp>
+      <p:sp>
+        <p:nvSpPr>
+          <p:cNvPr id="14" name="TextBox 13"/>
+          <p:cNvSpPr txBox="1"/>
+          <p:nvPr/>
+        </p:nvSpPr>
+        <p:spPr>
+          <a:xfrm>
+            <a:off x="667512" y="4279392"/>
+            <a:ext cx="10872216" cy="1362456"/>
+          </a:xfrm>
+          <a:prstGeom prst="rect">
+            <a:avLst/>
+          </a:prstGeom>
+          <a:noFill/>
+        </p:spPr>
+        <p:txBody>
+          <a:bodyPr wrap="square" lIns="0" rIns="0" tIns="0" bIns="0">
+            <a:spAutoFit/>
+          </a:bodyPr>
+          <a:lstStyle/>
+          <a:p>
+            <a:r>
+              <a:rPr sz="1300" b="1" spc="100">
+                <a:solidFill>
+                  <a:srgbClr val="C43A4B"/>
+                </a:solidFill>
+                <a:latin typeface="Cambria"/>
+              </a:rPr>
+              <a:t>THE OBSERVATION: 0.21 MI BETWEEN TWO RADIOS ON ONE DESK</a:t>
+            </a:r>
+          </a:p>
+          <a:p>
+            <a:r>
+              <a:rPr sz="1150">
+                <a:solidFill>
+                  <a:srgbClr val="222A3F"/>
+                </a:solidFill>
+                <a:latin typeface="Cambria"/>
+              </a:rPr>
+              <a:t>The displays were right and the GPS fixes were wrong. Indoors, SF's fix scattered 100 to 400 m between packets with 1.4 m/s of phantom speed; RG later reported a coherent 50 mph eastbound drive for a minute before snapping home. A marginal fix produces fake velocity, not just jitter, and dead reckoning faithfully projects it. Fixes shipped the same hour: the closing/apart line reads "holding" when both cars are parked; the distance stays honest. Rule: judge a bench distance only with sky view.</a:t>
+            </a:r>
+          </a:p>
+        </p:txBody>
+      </p:sp>
+    </p:spTree>
+  </p:cSld>
+  <p:clrMapOvr>
+    <a:masterClrMapping/>
+  </p:clrMapOvr>
+</p:sld>
+</file>
+
+<file path=ppt/slides/slide16.xml><?xml version="1.0" encoding="utf-8"?>
+<p:sld xmlns:a="http://schemas.openxmlformats.org/drawingml/2006/main" xmlns:p="http://schemas.openxmlformats.org/presentationml/2006/main" xmlns:r="http://schemas.openxmlformats.org/officeDocument/2006/relationships">
+  <p:cSld>
+    <p:spTree>
+      <p:nvGrpSpPr>
+        <p:cNvPr id="1" name=""/>
+        <p:cNvGrpSpPr/>
+        <p:nvPr/>
+      </p:nvGrpSpPr>
+      <p:grpSpPr/>
+      <p:sp>
+        <p:nvSpPr>
+          <p:cNvPr id="2" name="Rectangle 1"/>
+          <p:cNvSpPr/>
+          <p:nvPr/>
+        </p:nvSpPr>
+        <p:spPr>
+          <a:xfrm>
+            <a:off x="164592" y="146304"/>
+            <a:ext cx="11859768" cy="6565392"/>
+          </a:xfrm>
+          <a:prstGeom prst="rect">
+            <a:avLst/>
+          </a:prstGeom>
+          <a:noFill/>
+          <a:ln w="22225">
+            <a:solidFill>
+              <a:srgbClr val="16213D"/>
+            </a:solidFill>
+          </a:ln>
+          <a:effectLst/>
+        </p:spPr>
+        <p:style>
+          <a:lnRef idx="1">
+            <a:schemeClr val="accent1"/>
+          </a:lnRef>
+          <a:fillRef idx="3">
+            <a:schemeClr val="accent1"/>
+          </a:fillRef>
+          <a:effectRef idx="2">
+            <a:schemeClr val="accent1"/>
+          </a:effectRef>
+          <a:fontRef idx="minor">
+            <a:schemeClr val="lt1"/>
+          </a:fontRef>
+        </p:style>
+        <p:txBody>
+          <a:bodyPr rtlCol="0" anchor="ctr"/>
+          <a:lstStyle/>
+          <a:p>
+            <a:pPr algn="ctr"/>
+          </a:p>
+        </p:txBody>
+      </p:sp>
+      <p:sp>
+        <p:nvSpPr>
+          <p:cNvPr id="3" name="Rectangle 2"/>
+          <p:cNvSpPr/>
+          <p:nvPr/>
+        </p:nvSpPr>
+        <p:spPr>
+          <a:xfrm>
+            <a:off x="164592" y="6272784"/>
+            <a:ext cx="11859768" cy="12700"/>
+          </a:xfrm>
+          <a:prstGeom prst="rect">
+            <a:avLst/>
+          </a:prstGeom>
+          <a:solidFill>
+            <a:srgbClr val="16213D"/>
+          </a:solidFill>
+          <a:ln>
+            <a:noFill/>
+          </a:ln>
+          <a:effectLst/>
+        </p:spPr>
+        <p:style>
+          <a:lnRef idx="1">
+            <a:schemeClr val="accent1"/>
+          </a:lnRef>
+          <a:fillRef idx="3">
+            <a:schemeClr val="accent1"/>
+          </a:fillRef>
+          <a:effectRef idx="2">
+            <a:schemeClr val="accent1"/>
+          </a:effectRef>
+          <a:fontRef idx="minor">
+            <a:schemeClr val="lt1"/>
+          </a:fontRef>
+        </p:style>
+        <p:txBody>
+          <a:bodyPr rtlCol="0" anchor="ctr"/>
+          <a:lstStyle/>
+          <a:p>
+            <a:pPr algn="ctr"/>
+          </a:p>
+        </p:txBody>
+      </p:sp>
+      <p:sp>
+        <p:nvSpPr>
+          <p:cNvPr id="4" name="TextBox 3"/>
+          <p:cNvSpPr txBox="1"/>
+          <p:nvPr/>
+        </p:nvSpPr>
+        <p:spPr>
+          <a:xfrm>
+            <a:off x="320040" y="6345936"/>
+            <a:ext cx="4206240" cy="292608"/>
+          </a:xfrm>
+          <a:prstGeom prst="rect">
+            <a:avLst/>
+          </a:prstGeom>
+          <a:noFill/>
+        </p:spPr>
+        <p:txBody>
+          <a:bodyPr wrap="square" lIns="0" rIns="0" tIns="0" bIns="0">
+            <a:spAutoFit/>
+          </a:bodyPr>
+          <a:lstStyle/>
+          <a:p>
+            <a:pPr algn="l"/>
+            <a:r>
+              <a:rPr sz="900" b="0" i="0">
+                <a:solidFill>
+                  <a:srgbClr val="5E6B85"/>
+                </a:solidFill>
+                <a:latin typeface="Courier New"/>
+              </a:rPr>
+              <a:t>GROUP 9  |  OFF-GRID VEHICLE TRACKER</a:t>
+            </a:r>
+          </a:p>
+        </p:txBody>
+      </p:sp>
+      <p:sp>
+        <p:nvSpPr>
+          <p:cNvPr id="5" name="TextBox 4"/>
+          <p:cNvSpPr txBox="1"/>
+          <p:nvPr/>
+        </p:nvSpPr>
+        <p:spPr>
+          <a:xfrm>
+            <a:off x="4572000" y="6345936"/>
+            <a:ext cx="4206240" cy="292608"/>
+          </a:xfrm>
+          <a:prstGeom prst="rect">
+            <a:avLst/>
+          </a:prstGeom>
+          <a:noFill/>
+        </p:spPr>
+        <p:txBody>
+          <a:bodyPr wrap="square" lIns="0" rIns="0" tIns="0" bIns="0">
+            <a:spAutoFit/>
+          </a:bodyPr>
+          <a:lstStyle/>
+          <a:p>
+            <a:pPr algn="ctr"/>
+            <a:r>
+              <a:rPr sz="900" b="0" i="0">
+                <a:solidFill>
+                  <a:srgbClr val="5E6B85"/>
+                </a:solidFill>
+                <a:latin typeface="Courier New"/>
+              </a:rPr>
+              <a:t>PART II - THE TESTS</a:t>
+            </a:r>
+          </a:p>
+        </p:txBody>
+      </p:sp>
+      <p:sp>
+        <p:nvSpPr>
+          <p:cNvPr id="6" name="TextBox 5"/>
+          <p:cNvSpPr txBox="1"/>
+          <p:nvPr/>
+        </p:nvSpPr>
+        <p:spPr>
+          <a:xfrm>
+            <a:off x="8869680" y="6345936"/>
+            <a:ext cx="3017520" cy="292608"/>
+          </a:xfrm>
+          <a:prstGeom prst="rect">
+            <a:avLst/>
+          </a:prstGeom>
+          <a:noFill/>
+        </p:spPr>
+        <p:txBody>
+          <a:bodyPr wrap="square" lIns="0" rIns="0" tIns="0" bIns="0">
+            <a:spAutoFit/>
+          </a:bodyPr>
+          <a:lstStyle/>
+          <a:p>
+            <a:pPr algn="r"/>
+            <a:r>
+              <a:rPr sz="900" b="0" i="0">
+                <a:solidFill>
+                  <a:srgbClr val="5E6B85"/>
+                </a:solidFill>
+                <a:latin typeface="Courier New"/>
+              </a:rPr>
+              <a:t>SHEET 16/18  REV A  2026-10-24</a:t>
+            </a:r>
+          </a:p>
+        </p:txBody>
+      </p:sp>
+      <p:sp>
+        <p:nvSpPr>
+          <p:cNvPr id="7" name="Rectangle 6"/>
+          <p:cNvSpPr/>
+          <p:nvPr/>
+        </p:nvSpPr>
+        <p:spPr>
+          <a:xfrm>
+            <a:off x="9646920" y="347472"/>
+            <a:ext cx="2148840" cy="420624"/>
+          </a:xfrm>
+          <a:prstGeom prst="rect">
+            <a:avLst/>
+          </a:prstGeom>
+          <a:solidFill>
+            <a:srgbClr val="FFFFFF"/>
+          </a:solidFill>
+          <a:ln w="19050">
+            <a:solidFill>
+              <a:srgbClr val="1199BD"/>
+            </a:solidFill>
+          </a:ln>
+          <a:effectLst/>
+        </p:spPr>
+        <p:style>
+          <a:lnRef idx="1">
+            <a:schemeClr val="accent1"/>
+          </a:lnRef>
+          <a:fillRef idx="3">
+            <a:schemeClr val="accent1"/>
+          </a:fillRef>
+          <a:effectRef idx="2">
+            <a:schemeClr val="accent1"/>
+          </a:effectRef>
+          <a:fontRef idx="minor">
+            <a:schemeClr val="lt1"/>
+          </a:fontRef>
+        </p:style>
+        <p:txBody>
+          <a:bodyPr rtlCol="0" anchor="ctr"/>
+          <a:lstStyle/>
+          <a:p>
+            <a:pPr algn="ctr"/>
+          </a:p>
+        </p:txBody>
+      </p:sp>
+      <p:sp>
+        <p:nvSpPr>
+          <p:cNvPr id="8" name="TextBox 7"/>
+          <p:cNvSpPr txBox="1"/>
+          <p:nvPr/>
+        </p:nvSpPr>
+        <p:spPr>
+          <a:xfrm>
+            <a:off x="9646920" y="402336"/>
+            <a:ext cx="2148840" cy="310896"/>
+          </a:xfrm>
+          <a:prstGeom prst="rect">
+            <a:avLst/>
+          </a:prstGeom>
+          <a:noFill/>
+        </p:spPr>
+        <p:txBody>
+          <a:bodyPr wrap="square" lIns="0" rIns="0" tIns="0" bIns="0">
+            <a:spAutoFit/>
+          </a:bodyPr>
+          <a:lstStyle/>
+          <a:p>
+            <a:pPr algn="ctr"/>
+            <a:r>
+              <a:rPr sz="1100" b="1" i="0">
+                <a:solidFill>
+                  <a:srgbClr val="1199BD"/>
+                </a:solidFill>
+                <a:latin typeface="Courier New"/>
+              </a:rPr>
+              <a:t>OWNER: DEO</a:t>
+            </a:r>
+          </a:p>
+        </p:txBody>
+      </p:sp>
+      <p:sp>
+        <p:nvSpPr>
+          <p:cNvPr id="9" name="TextBox 8"/>
+          <p:cNvSpPr txBox="1"/>
+          <p:nvPr/>
+        </p:nvSpPr>
+        <p:spPr>
+          <a:xfrm>
+            <a:off x="457200" y="329184"/>
+            <a:ext cx="9052560" cy="566928"/>
+          </a:xfrm>
+          <a:prstGeom prst="rect">
+            <a:avLst/>
+          </a:prstGeom>
+          <a:noFill/>
+        </p:spPr>
+        <p:txBody>
+          <a:bodyPr wrap="square" lIns="0" rIns="0" tIns="0" bIns="0">
+            <a:spAutoFit/>
+          </a:bodyPr>
+          <a:lstStyle/>
+          <a:p>
+            <a:pPr algn="l"/>
+            <a:r>
+              <a:rPr sz="2300" b="1" i="0" spc="200">
+                <a:solidFill>
+                  <a:srgbClr val="16213D"/>
+                </a:solidFill>
+                <a:latin typeface="Cambria"/>
+              </a:rPr>
+              <a:t>PRE-DRIVE DIAGNOSTIC, OCT 24: THE RADIOS</a:t>
+            </a:r>
+          </a:p>
+        </p:txBody>
+      </p:sp>
+      <p:graphicFrame>
+        <p:nvGraphicFramePr>
+          <p:cNvPr id="10" name="Table 9"/>
+          <p:cNvGraphicFramePr>
+            <a:graphicFrameLocks noGrp="1"/>
+          </p:cNvGraphicFramePr>
+          <p:nvPr/>
+        </p:nvGraphicFramePr>
+        <p:xfrm>
+          <a:off x="502920" y="1188720"/>
+          <a:ext cx="11155680" cy="4206240"/>
+        </p:xfrm>
+        <a:graphic>
+          <a:graphicData uri="http://schemas.openxmlformats.org/drawingml/2006/table">
+            <a:tbl>
+              <a:tblPr firstRow="1" bandRow="1">
+                <a:tableStyleId>{5C22544A-7EE6-4342-B048-85BDC9FD1C3A}</a:tableStyleId>
+              </a:tblPr>
+              <a:tblGrid>
+                <a:gridCol w="2377440"/>
+                <a:gridCol w="4389120"/>
+                <a:gridCol w="4389120"/>
+              </a:tblGrid>
+              <a:tr h="420624">
+                <a:tc>
+                  <a:txBody>
+                    <a:bodyPr/>
+                    <a:lstStyle/>
+                    <a:p>
+                      <a:r>
+                        <a:rPr sz="1100" b="1">
+                          <a:solidFill>
+                            <a:srgbClr val="FFFFFF"/>
+                          </a:solidFill>
+                          <a:latin typeface="Cambria"/>
+                        </a:rPr>
+                        <a:t>Check</a:t>
+                      </a:r>
+                    </a:p>
+                  </a:txBody>
+                  <a:tcPr marL="73152" marR="73152" marT="27432" marB="27432">
+                    <a:solidFill>
+                      <a:srgbClr val="16213D"/>
+                    </a:solidFill>
+                  </a:tcPr>
+                </a:tc>
+                <a:tc>
+                  <a:txBody>
+                    <a:bodyPr/>
+                    <a:lstStyle/>
+                    <a:p>
+                      <a:r>
+                        <a:rPr sz="1100" b="1">
+                          <a:solidFill>
+                            <a:srgbClr val="FFFFFF"/>
+                          </a:solidFill>
+                          <a:latin typeface="Cambria"/>
+                        </a:rPr>
+                        <a:t>SF (EA:D4)</a:t>
+                      </a:r>
+                    </a:p>
+                  </a:txBody>
+                  <a:tcPr marL="73152" marR="73152" marT="27432" marB="27432">
+                    <a:solidFill>
+                      <a:srgbClr val="16213D"/>
+                    </a:solidFill>
+                  </a:tcPr>
+                </a:tc>
+                <a:tc>
+                  <a:txBody>
+                    <a:bodyPr/>
+                    <a:lstStyle/>
+                    <a:p>
+                      <a:r>
+                        <a:rPr sz="1100" b="1">
+                          <a:solidFill>
+                            <a:srgbClr val="FFFFFF"/>
+                          </a:solidFill>
+                          <a:latin typeface="Cambria"/>
+                        </a:rPr>
+                        <a:t>RG (BB:5C)</a:t>
+                      </a:r>
+                    </a:p>
+                  </a:txBody>
+                  <a:tcPr marL="73152" marR="73152" marT="27432" marB="27432">
+                    <a:solidFill>
+                      <a:srgbClr val="16213D"/>
+                    </a:solidFill>
+                  </a:tcPr>
+                </a:tc>
+              </a:tr>
+              <a:tr h="420624">
+                <a:tc>
+                  <a:txBody>
+                    <a:bodyPr/>
+                    <a:lstStyle/>
+                    <a:p>
+                      <a:r>
+                        <a:rPr sz="1100" b="0">
+                          <a:solidFill>
+                            <a:srgbClr val="222A3F"/>
+                          </a:solidFill>
+                          <a:latin typeface="Cambria"/>
+                        </a:rPr>
+                        <a:t>Channel 0</a:t>
+                      </a:r>
+                    </a:p>
+                  </a:txBody>
+                  <a:tcPr marL="73152" marR="73152" marT="27432" marB="27432">
+                    <a:solidFill>
+                      <a:srgbClr val="F2F5FA"/>
+                    </a:solidFill>
+                  </a:tcPr>
+                </a:tc>
+                <a:tc>
+                  <a:txBody>
+                    <a:bodyPr/>
+                    <a:lstStyle/>
+                    <a:p>
+                      <a:r>
+                        <a:rPr sz="1100" b="0">
+                          <a:solidFill>
+                            <a:srgbClr val="222A3F"/>
+                          </a:solidFill>
+                          <a:latin typeface="Cambria"/>
+                        </a:rPr>
+                        <a:t>Group9, 32-byte key, precision 32</a:t>
+                      </a:r>
+                    </a:p>
+                  </a:txBody>
+                  <a:tcPr marL="73152" marR="73152" marT="27432" marB="27432">
+                    <a:solidFill>
+                      <a:srgbClr val="F2F5FA"/>
+                    </a:solidFill>
+                  </a:tcPr>
+                </a:tc>
+                <a:tc>
+                  <a:txBody>
+                    <a:bodyPr/>
+                    <a:lstStyle/>
+                    <a:p>
+                      <a:r>
+                        <a:rPr sz="1100" b="0">
+                          <a:solidFill>
+                            <a:srgbClr val="222A3F"/>
+                          </a:solidFill>
+                          <a:latin typeface="Cambria"/>
+                        </a:rPr>
+                        <a:t>Group9, 32-byte key, precision 32</a:t>
+                      </a:r>
+                    </a:p>
+                  </a:txBody>
+                  <a:tcPr marL="73152" marR="73152" marT="27432" marB="27432">
+                    <a:solidFill>
+                      <a:srgbClr val="F2F5FA"/>
+                    </a:solidFill>
+                  </a:tcPr>
+                </a:tc>
+              </a:tr>
+              <a:tr h="420624">
+                <a:tc>
+                  <a:txBody>
+                    <a:bodyPr/>
+                    <a:lstStyle/>
+                    <a:p>
+                      <a:r>
+                        <a:rPr sz="1100" b="0">
+                          <a:solidFill>
+                            <a:srgbClr val="222A3F"/>
+                          </a:solidFill>
+                          <a:latin typeface="Cambria"/>
+                        </a:rPr>
+                        <a:t>Role / Bluetooth</a:t>
+                      </a:r>
+                    </a:p>
+                  </a:txBody>
+                  <a:tcPr marL="73152" marR="73152" marT="27432" marB="27432">
+                    <a:solidFill>
+                      <a:srgbClr val="FFFFFF"/>
+                    </a:solidFill>
+                  </a:tcPr>
+                </a:tc>
+                <a:tc>
+                  <a:txBody>
+                    <a:bodyPr/>
+                    <a:lstStyle/>
+                    <a:p>
+                      <a:r>
+                        <a:rPr sz="1100" b="0">
+                          <a:solidFill>
+                            <a:srgbClr val="222A3F"/>
+                          </a:solidFill>
+                          <a:latin typeface="Cambria"/>
+                        </a:rPr>
+                        <a:t>CLIENT_MUTE / No PIN</a:t>
+                      </a:r>
+                    </a:p>
+                  </a:txBody>
+                  <a:tcPr marL="73152" marR="73152" marT="27432" marB="27432">
+                    <a:solidFill>
+                      <a:srgbClr val="FFFFFF"/>
+                    </a:solidFill>
+                  </a:tcPr>
+                </a:tc>
+                <a:tc>
+                  <a:txBody>
+                    <a:bodyPr/>
+                    <a:lstStyle/>
+                    <a:p>
+                      <a:r>
+                        <a:rPr sz="1100" b="0">
+                          <a:solidFill>
+                            <a:srgbClr val="222A3F"/>
+                          </a:solidFill>
+                          <a:latin typeface="Cambria"/>
+                        </a:rPr>
+                        <a:t>CLIENT_MUTE / No PIN</a:t>
+                      </a:r>
+                    </a:p>
+                  </a:txBody>
+                  <a:tcPr marL="73152" marR="73152" marT="27432" marB="27432">
+                    <a:solidFill>
+                      <a:srgbClr val="FFFFFF"/>
+                    </a:solidFill>
+                  </a:tcPr>
+                </a:tc>
+              </a:tr>
+              <a:tr h="420624">
+                <a:tc>
+                  <a:txBody>
+                    <a:bodyPr/>
+                    <a:lstStyle/>
+                    <a:p>
+                      <a:r>
+                        <a:rPr sz="1100" b="0">
+                          <a:solidFill>
+                            <a:srgbClr val="222A3F"/>
+                          </a:solidFill>
+                          <a:latin typeface="Cambria"/>
+                        </a:rPr>
+                        <a:t>Position cadence</a:t>
+                      </a:r>
+                    </a:p>
+                  </a:txBody>
+                  <a:tcPr marL="73152" marR="73152" marT="27432" marB="27432">
+                    <a:solidFill>
+                      <a:srgbClr val="F2F5FA"/>
+                    </a:solidFill>
+                  </a:tcPr>
+                </a:tc>
+                <a:tc>
+                  <a:txBody>
+                    <a:bodyPr/>
+                    <a:lstStyle/>
+                    <a:p>
+                      <a:r>
+                        <a:rPr sz="1100" b="0">
+                          <a:solidFill>
+                            <a:srgbClr val="222A3F"/>
+                          </a:solidFill>
+                          <a:latin typeface="Cambria"/>
+                        </a:rPr>
+                        <a:t>60 s, smart 10 s / 20 m, GPS 10 s</a:t>
+                      </a:r>
+                    </a:p>
+                  </a:txBody>
+                  <a:tcPr marL="73152" marR="73152" marT="27432" marB="27432">
+                    <a:solidFill>
+                      <a:srgbClr val="F2F5FA"/>
+                    </a:solidFill>
+                  </a:tcPr>
+                </a:tc>
+                <a:tc>
+                  <a:txBody>
+                    <a:bodyPr/>
+                    <a:lstStyle/>
+                    <a:p>
+                      <a:r>
+                        <a:rPr sz="1100" b="0">
+                          <a:solidFill>
+                            <a:srgbClr val="222A3F"/>
+                          </a:solidFill>
+                          <a:latin typeface="Cambria"/>
+                        </a:rPr>
+                        <a:t>60 s, smart 10 s / 20 m, GPS 10 s</a:t>
+                      </a:r>
+                    </a:p>
+                  </a:txBody>
+                  <a:tcPr marL="73152" marR="73152" marT="27432" marB="27432">
+                    <a:solidFill>
+                      <a:srgbClr val="F2F5FA"/>
+                    </a:solidFill>
+                  </a:tcPr>
+                </a:tc>
+              </a:tr>
+              <a:tr h="420624">
+                <a:tc>
+                  <a:txBody>
+                    <a:bodyPr/>
+                    <a:lstStyle/>
+                    <a:p>
+                      <a:r>
+                        <a:rPr sz="1100" b="0">
+                          <a:solidFill>
+                            <a:srgbClr val="222A3F"/>
+                          </a:solidFill>
+                          <a:latin typeface="Cambria"/>
+                        </a:rPr>
+                        <a:t>Telemetry heartbeat</a:t>
+                      </a:r>
+                    </a:p>
+                  </a:txBody>
+                  <a:tcPr marL="73152" marR="73152" marT="27432" marB="27432">
+                    <a:solidFill>
+                      <a:srgbClr val="FFFFFF"/>
+                    </a:solidFill>
+                  </a:tcPr>
+                </a:tc>
+                <a:tc>
+                  <a:txBody>
+                    <a:bodyPr/>
+                    <a:lstStyle/>
+                    <a:p>
+                      <a:r>
+                        <a:rPr sz="1100" b="0">
+                          <a:solidFill>
+                            <a:srgbClr val="222A3F"/>
+                          </a:solidFill>
+                          <a:latin typeface="Cambria"/>
+                        </a:rPr>
+                        <a:t>was OFF (leftover of the morning revert): set to 300 s</a:t>
+                      </a:r>
+                    </a:p>
+                  </a:txBody>
+                  <a:tcPr marL="73152" marR="73152" marT="27432" marB="27432">
+                    <a:solidFill>
+                      <a:srgbClr val="FFFFFF"/>
+                    </a:solidFill>
+                  </a:tcPr>
+                </a:tc>
+                <a:tc>
+                  <a:txBody>
+                    <a:bodyPr/>
+                    <a:lstStyle/>
+                    <a:p>
+                      <a:r>
+                        <a:rPr sz="1100" b="0">
+                          <a:solidFill>
+                            <a:srgbClr val="222A3F"/>
+                          </a:solidFill>
+                          <a:latin typeface="Cambria"/>
+                        </a:rPr>
+                        <a:t>300 s</a:t>
+                      </a:r>
+                    </a:p>
+                  </a:txBody>
+                  <a:tcPr marL="73152" marR="73152" marT="27432" marB="27432">
+                    <a:solidFill>
+                      <a:srgbClr val="FFFFFF"/>
+                    </a:solidFill>
+                  </a:tcPr>
+                </a:tc>
+              </a:tr>
+              <a:tr h="420624">
+                <a:tc>
+                  <a:txBody>
+                    <a:bodyPr/>
+                    <a:lstStyle/>
+                    <a:p>
+                      <a:r>
+                        <a:rPr sz="1100" b="0">
+                          <a:solidFill>
+                            <a:srgbClr val="222A3F"/>
+                          </a:solidFill>
+                          <a:latin typeface="Cambria"/>
+                        </a:rPr>
+                        <a:t>Owner</a:t>
+                      </a:r>
+                    </a:p>
+                  </a:txBody>
+                  <a:tcPr marL="73152" marR="73152" marT="27432" marB="27432">
+                    <a:solidFill>
+                      <a:srgbClr val="F2F5FA"/>
+                    </a:solidFill>
+                  </a:tcPr>
+                </a:tc>
+                <a:tc>
+                  <a:txBody>
+                    <a:bodyPr/>
+                    <a:lstStyle/>
+                    <a:p>
+                      <a:r>
+                        <a:rPr sz="1100" b="0">
+                          <a:solidFill>
+                            <a:srgbClr val="222A3F"/>
+                          </a:solidFill>
+                          <a:latin typeface="Cambria"/>
+                        </a:rPr>
+                        <a:t>SF / SF</a:t>
+                      </a:r>
+                    </a:p>
+                  </a:txBody>
+                  <a:tcPr marL="73152" marR="73152" marT="27432" marB="27432">
+                    <a:solidFill>
+                      <a:srgbClr val="F2F5FA"/>
+                    </a:solidFill>
+                  </a:tcPr>
+                </a:tc>
+                <a:tc>
+                  <a:txBody>
+                    <a:bodyPr/>
+                    <a:lstStyle/>
+                    <a:p>
+                      <a:r>
+                        <a:rPr sz="1100" b="0">
+                          <a:solidFill>
+                            <a:srgbClr val="222A3F"/>
+                          </a:solidFill>
+                          <a:latin typeface="Cambria"/>
+                        </a:rPr>
+                        <a:t>was "Meshtastic bb5c": set to RG / RG</a:t>
+                      </a:r>
+                    </a:p>
+                  </a:txBody>
+                  <a:tcPr marL="73152" marR="73152" marT="27432" marB="27432">
+                    <a:solidFill>
+                      <a:srgbClr val="F2F5FA"/>
+                    </a:solidFill>
+                  </a:tcPr>
+                </a:tc>
+              </a:tr>
+              <a:tr h="420624">
+                <a:tc>
+                  <a:txBody>
+                    <a:bodyPr/>
+                    <a:lstStyle/>
+                    <a:p>
+                      <a:r>
+                        <a:rPr sz="1100" b="0">
+                          <a:solidFill>
+                            <a:srgbClr val="222A3F"/>
+                          </a:solidFill>
+                          <a:latin typeface="Cambria"/>
+                        </a:rPr>
+                        <a:t>Battery</a:t>
+                      </a:r>
+                    </a:p>
+                  </a:txBody>
+                  <a:tcPr marL="73152" marR="73152" marT="27432" marB="27432">
+                    <a:solidFill>
+                      <a:srgbClr val="FFFFFF"/>
+                    </a:solidFill>
+                  </a:tcPr>
+                </a:tc>
+                <a:tc>
+                  <a:txBody>
+                    <a:bodyPr/>
+                    <a:lstStyle/>
+                    <a:p>
+                      <a:r>
+                        <a:rPr sz="1100" b="0">
+                          <a:solidFill>
+                            <a:srgbClr val="222A3F"/>
+                          </a:solidFill>
+                          <a:latin typeface="Cambria"/>
+                        </a:rPr>
+                        <a:t>96 % (4.15 V)</a:t>
+                      </a:r>
+                    </a:p>
+                  </a:txBody>
+                  <a:tcPr marL="73152" marR="73152" marT="27432" marB="27432">
+                    <a:solidFill>
+                      <a:srgbClr val="FFFFFF"/>
+                    </a:solidFill>
+                  </a:tcPr>
+                </a:tc>
+                <a:tc>
+                  <a:txBody>
+                    <a:bodyPr/>
+                    <a:lstStyle/>
+                    <a:p>
+                      <a:r>
+                        <a:rPr sz="1100" b="0">
+                          <a:solidFill>
+                            <a:srgbClr val="222A3F"/>
+                          </a:solidFill>
+                          <a:latin typeface="Cambria"/>
+                        </a:rPr>
+                        <a:t>69 % (3.88 V): charge before the drive</a:t>
+                      </a:r>
+                    </a:p>
+                  </a:txBody>
+                  <a:tcPr marL="73152" marR="73152" marT="27432" marB="27432">
+                    <a:solidFill>
+                      <a:srgbClr val="FFFFFF"/>
+                    </a:solidFill>
+                  </a:tcPr>
+                </a:tc>
+              </a:tr>
+              <a:tr h="420624">
+                <a:tc>
+                  <a:txBody>
+                    <a:bodyPr/>
+                    <a:lstStyle/>
+                    <a:p>
+                      <a:r>
+                        <a:rPr sz="1100" b="0">
+                          <a:solidFill>
+                            <a:srgbClr val="222A3F"/>
+                          </a:solidFill>
+                          <a:latin typeface="Cambria"/>
+                        </a:rPr>
+                        <a:t>Own GPS, indoors</a:t>
+                      </a:r>
+                    </a:p>
+                  </a:txBody>
+                  <a:tcPr marL="73152" marR="73152" marT="27432" marB="27432">
+                    <a:solidFill>
+                      <a:srgbClr val="F2F5FA"/>
+                    </a:solidFill>
+                  </a:tcPr>
+                </a:tc>
+                <a:tc>
+                  <a:txBody>
+                    <a:bodyPr/>
+                    <a:lstStyle/>
+                    <a:p>
+                      <a:r>
+                        <a:rPr sz="1100" b="0">
+                          <a:solidFill>
+                            <a:srgbClr val="222A3F"/>
+                          </a:solidFill>
+                          <a:latin typeface="Cambria"/>
+                        </a:rPr>
+                        <a:t>fix at 14:27, alt 1398 m</a:t>
+                      </a:r>
+                    </a:p>
+                  </a:txBody>
+                  <a:tcPr marL="73152" marR="73152" marT="27432" marB="27432">
+                    <a:solidFill>
+                      <a:srgbClr val="F2F5FA"/>
+                    </a:solidFill>
+                  </a:tcPr>
+                </a:tc>
+                <a:tc>
+                  <a:txBody>
+                    <a:bodyPr/>
+                    <a:lstStyle/>
+                    <a:p>
+                      <a:r>
+                        <a:rPr sz="1100" b="0">
+                          <a:solidFill>
+                            <a:srgbClr val="222A3F"/>
+                          </a:solidFill>
+                          <a:latin typeface="Cambria"/>
+                        </a:rPr>
+                        <a:t>no fix: the radio that showed the phantom drive</a:t>
+                      </a:r>
+                    </a:p>
+                  </a:txBody>
+                  <a:tcPr marL="73152" marR="73152" marT="27432" marB="27432">
+                    <a:solidFill>
+                      <a:srgbClr val="F2F5FA"/>
+                    </a:solidFill>
+                  </a:tcPr>
+                </a:tc>
+              </a:tr>
+              <a:tr h="420624">
+                <a:tc>
+                  <a:txBody>
+                    <a:bodyPr/>
+                    <a:lstStyle/>
+                    <a:p>
+                      <a:r>
+                        <a:rPr sz="1100" b="0">
+                          <a:solidFill>
+                            <a:srgbClr val="222A3F"/>
+                          </a:solidFill>
+                          <a:latin typeface="Cambria"/>
+                        </a:rPr>
+                        <a:t>Heard the partner</a:t>
+                      </a:r>
+                    </a:p>
+                  </a:txBody>
+                  <a:tcPr marL="73152" marR="73152" marT="27432" marB="27432">
+                    <a:solidFill>
+                      <a:srgbClr val="FFFFFF"/>
+                    </a:solidFill>
+                  </a:tcPr>
+                </a:tc>
+                <a:tc>
+                  <a:txBody>
+                    <a:bodyPr/>
+                    <a:lstStyle/>
+                    <a:p>
+                      <a:r>
+                        <a:rPr sz="1100" b="0">
+                          <a:solidFill>
+                            <a:srgbClr val="222A3F"/>
+                          </a:solidFill>
+                          <a:latin typeface="Cambria"/>
+                        </a:rPr>
+                        <a:t>RG 1.1 min ago, 6.25 dB</a:t>
+                      </a:r>
+                    </a:p>
+                  </a:txBody>
+                  <a:tcPr marL="73152" marR="73152" marT="27432" marB="27432">
+                    <a:solidFill>
+                      <a:srgbClr val="FFFFFF"/>
+                    </a:solidFill>
+                  </a:tcPr>
+                </a:tc>
+                <a:tc>
+                  <a:txBody>
+                    <a:bodyPr/>
+                    <a:lstStyle/>
+                    <a:p>
+                      <a:r>
+                        <a:rPr sz="1100" b="0">
+                          <a:solidFill>
+                            <a:srgbClr val="222A3F"/>
+                          </a:solidFill>
+                          <a:latin typeface="Cambria"/>
+                        </a:rPr>
+                        <a:t>SF 0.6 min ago, 6.5 dB</a:t>
+                      </a:r>
+                    </a:p>
+                  </a:txBody>
+                  <a:tcPr marL="73152" marR="73152" marT="27432" marB="27432">
+                    <a:solidFill>
+                      <a:srgbClr val="FFFFFF"/>
+                    </a:solidFill>
+                  </a:tcPr>
+                </a:tc>
+              </a:tr>
+              <a:tr h="420624">
+                <a:tc>
+                  <a:txBody>
+                    <a:bodyPr/>
+                    <a:lstStyle/>
+                    <a:p>
+                      <a:r>
+                        <a:rPr sz="1100" b="0">
+                          <a:solidFill>
+                            <a:srgbClr val="222A3F"/>
+                          </a:solidFill>
+                          <a:latin typeface="Cambria"/>
+                        </a:rPr>
+                        <a:t>OLED LoRa screen</a:t>
+                      </a:r>
+                    </a:p>
+                  </a:txBody>
+                  <a:tcPr marL="73152" marR="73152" marT="27432" marB="27432">
+                    <a:solidFill>
+                      <a:srgbClr val="F2F5FA"/>
+                    </a:solidFill>
+                  </a:tcPr>
+                </a:tc>
+                <a:tc>
+                  <a:txBody>
+                    <a:bodyPr/>
+                    <a:lstStyle/>
+                    <a:p>
+                      <a:r>
+                        <a:rPr sz="1100" b="0">
+                          <a:solidFill>
+                            <a:srgbClr val="222A3F"/>
+                          </a:solidFill>
+                          <a:latin typeface="Cambria"/>
+                        </a:rPr>
+                        <a:t>912.875 MHz</a:t>
+                      </a:r>
+                    </a:p>
+                  </a:txBody>
+                  <a:tcPr marL="73152" marR="73152" marT="27432" marB="27432">
+                    <a:solidFill>
+                      <a:srgbClr val="F2F5FA"/>
+                    </a:solidFill>
+                  </a:tcPr>
+                </a:tc>
+                <a:tc>
+                  <a:txBody>
+                    <a:bodyPr/>
+                    <a:lstStyle/>
+                    <a:p>
+                      <a:r>
+                        <a:rPr sz="1100" b="0">
+                          <a:solidFill>
+                            <a:srgbClr val="222A3F"/>
+                          </a:solidFill>
+                          <a:latin typeface="Cambria"/>
+                        </a:rPr>
+                        <a:t>912.875 MHz</a:t>
+                      </a:r>
+                    </a:p>
+                  </a:txBody>
+                  <a:tcPr marL="73152" marR="73152" marT="27432" marB="27432">
+                    <a:solidFill>
+                      <a:srgbClr val="F2F5FA"/>
+                    </a:solidFill>
+                  </a:tcPr>
+                </a:tc>
+              </a:tr>
+            </a:tbl>
+          </a:graphicData>
+        </a:graphic>
+      </p:graphicFrame>
+      <p:sp>
+        <p:nvSpPr>
+          <p:cNvPr id="11" name="Rectangle 10"/>
+          <p:cNvSpPr/>
+          <p:nvPr/>
+        </p:nvSpPr>
+        <p:spPr>
+          <a:xfrm>
+            <a:off x="502920" y="5486400"/>
+            <a:ext cx="11155680" cy="658368"/>
+          </a:xfrm>
+          <a:prstGeom prst="rect">
+            <a:avLst/>
+          </a:prstGeom>
+          <a:solidFill>
+            <a:srgbClr val="F2F5FA"/>
+          </a:solidFill>
+          <a:ln w="15875">
+            <a:solidFill>
+              <a:srgbClr val="1F9D68"/>
+            </a:solidFill>
+          </a:ln>
+          <a:effectLst/>
+        </p:spPr>
+        <p:style>
+          <a:lnRef idx="1">
+            <a:schemeClr val="accent1"/>
+          </a:lnRef>
+          <a:fillRef idx="3">
+            <a:schemeClr val="accent1"/>
+          </a:fillRef>
+          <a:effectRef idx="2">
+            <a:schemeClr val="accent1"/>
+          </a:effectRef>
+          <a:fontRef idx="minor">
+            <a:schemeClr val="lt1"/>
+          </a:fontRef>
+        </p:style>
+        <p:txBody>
+          <a:bodyPr rtlCol="0" anchor="ctr"/>
+          <a:lstStyle/>
+          <a:p>
+            <a:pPr algn="ctr"/>
+          </a:p>
+        </p:txBody>
+      </p:sp>
+      <p:sp>
+        <p:nvSpPr>
+          <p:cNvPr id="12" name="TextBox 11"/>
+          <p:cNvSpPr txBox="1"/>
+          <p:nvPr/>
+        </p:nvSpPr>
+        <p:spPr>
+          <a:xfrm>
+            <a:off x="667512" y="5605272"/>
+            <a:ext cx="10826496" cy="420623"/>
+          </a:xfrm>
+          <a:prstGeom prst="rect">
+            <a:avLst/>
+          </a:prstGeom>
+          <a:noFill/>
+        </p:spPr>
+        <p:txBody>
+          <a:bodyPr wrap="square" lIns="0" rIns="0" tIns="0" bIns="0">
+            <a:spAutoFit/>
+          </a:bodyPr>
+          <a:lstStyle/>
+          <a:p>
+            <a:r>
+              <a:rPr sz="1200" b="1" spc="100">
+                <a:solidFill>
+                  <a:srgbClr val="1F9D68"/>
+                </a:solidFill>
+                <a:latin typeface="Cambria"/>
+              </a:rPr>
+              <a:t>RESULT</a:t>
+            </a:r>
+          </a:p>
+          <a:p>
+            <a:r>
+              <a:rPr sz="1100">
+                <a:solidFill>
+                  <a:srgbClr val="222A3F"/>
+                </a:solidFill>
+                <a:latin typeface="Cambria"/>
+              </a:rPr>
+              <a:t>Both radios fully provisioned and in agreement; link at the September figure (~6.5 dB); config snapshots re-exported. Both displays showed the link on the first power-cycle after unplugging.</a:t>
+            </a:r>
+          </a:p>
+        </p:txBody>
+      </p:sp>
+    </p:spTree>
+  </p:cSld>
+  <p:clrMapOvr>
+    <a:masterClrMapping/>
+  </p:clrMapOvr>
+</p:sld>
+</file>
+
+<file path=ppt/slides/slide17.xml><?xml version="1.0" encoding="utf-8"?>
+<p:sld xmlns:a="http://schemas.openxmlformats.org/drawingml/2006/main" xmlns:p="http://schemas.openxmlformats.org/presentationml/2006/main" xmlns:r="http://schemas.openxmlformats.org/officeDocument/2006/relationships">
+  <p:cSld>
+    <p:spTree>
+      <p:nvGrpSpPr>
+        <p:cNvPr id="1" name=""/>
+        <p:cNvGrpSpPr/>
+        <p:nvPr/>
+      </p:nvGrpSpPr>
+      <p:grpSpPr/>
+      <p:sp>
+        <p:nvSpPr>
+          <p:cNvPr id="2" name="Rectangle 1"/>
+          <p:cNvSpPr/>
+          <p:nvPr/>
+        </p:nvSpPr>
+        <p:spPr>
+          <a:xfrm>
+            <a:off x="164592" y="146304"/>
+            <a:ext cx="11859768" cy="6565392"/>
+          </a:xfrm>
+          <a:prstGeom prst="rect">
+            <a:avLst/>
+          </a:prstGeom>
+          <a:noFill/>
+          <a:ln w="22225">
+            <a:solidFill>
+              <a:srgbClr val="16213D"/>
+            </a:solidFill>
+          </a:ln>
+          <a:effectLst/>
+        </p:spPr>
+        <p:style>
+          <a:lnRef idx="1">
+            <a:schemeClr val="accent1"/>
+          </a:lnRef>
+          <a:fillRef idx="3">
+            <a:schemeClr val="accent1"/>
+          </a:fillRef>
+          <a:effectRef idx="2">
+            <a:schemeClr val="accent1"/>
+          </a:effectRef>
+          <a:fontRef idx="minor">
+            <a:schemeClr val="lt1"/>
+          </a:fontRef>
+        </p:style>
+        <p:txBody>
+          <a:bodyPr rtlCol="0" anchor="ctr"/>
+          <a:lstStyle/>
+          <a:p>
+            <a:pPr algn="ctr"/>
+          </a:p>
+        </p:txBody>
+      </p:sp>
+      <p:sp>
+        <p:nvSpPr>
+          <p:cNvPr id="3" name="Rectangle 2"/>
+          <p:cNvSpPr/>
+          <p:nvPr/>
+        </p:nvSpPr>
+        <p:spPr>
+          <a:xfrm>
+            <a:off x="164592" y="6272784"/>
+            <a:ext cx="11859768" cy="12700"/>
+          </a:xfrm>
+          <a:prstGeom prst="rect">
+            <a:avLst/>
+          </a:prstGeom>
+          <a:solidFill>
+            <a:srgbClr val="16213D"/>
+          </a:solidFill>
+          <a:ln>
+            <a:noFill/>
+          </a:ln>
+          <a:effectLst/>
+        </p:spPr>
+        <p:style>
+          <a:lnRef idx="1">
+            <a:schemeClr val="accent1"/>
+          </a:lnRef>
+          <a:fillRef idx="3">
+            <a:schemeClr val="accent1"/>
+          </a:fillRef>
+          <a:effectRef idx="2">
+            <a:schemeClr val="accent1"/>
+          </a:effectRef>
+          <a:fontRef idx="minor">
+            <a:schemeClr val="lt1"/>
+          </a:fontRef>
+        </p:style>
+        <p:txBody>
+          <a:bodyPr rtlCol="0" anchor="ctr"/>
+          <a:lstStyle/>
+          <a:p>
+            <a:pPr algn="ctr"/>
+          </a:p>
+        </p:txBody>
+      </p:sp>
+      <p:sp>
+        <p:nvSpPr>
+          <p:cNvPr id="4" name="TextBox 3"/>
+          <p:cNvSpPr txBox="1"/>
+          <p:nvPr/>
+        </p:nvSpPr>
+        <p:spPr>
+          <a:xfrm>
+            <a:off x="320040" y="6345936"/>
+            <a:ext cx="4206240" cy="292608"/>
+          </a:xfrm>
+          <a:prstGeom prst="rect">
+            <a:avLst/>
+          </a:prstGeom>
+          <a:noFill/>
+        </p:spPr>
+        <p:txBody>
+          <a:bodyPr wrap="square" lIns="0" rIns="0" tIns="0" bIns="0">
+            <a:spAutoFit/>
+          </a:bodyPr>
+          <a:lstStyle/>
+          <a:p>
+            <a:pPr algn="l"/>
+            <a:r>
+              <a:rPr sz="900" b="0" i="0">
+                <a:solidFill>
+                  <a:srgbClr val="5E6B85"/>
+                </a:solidFill>
+                <a:latin typeface="Courier New"/>
+              </a:rPr>
+              <a:t>GROUP 9  |  OFF-GRID VEHICLE TRACKER</a:t>
+            </a:r>
+          </a:p>
+        </p:txBody>
+      </p:sp>
+      <p:sp>
+        <p:nvSpPr>
+          <p:cNvPr id="5" name="TextBox 4"/>
+          <p:cNvSpPr txBox="1"/>
+          <p:nvPr/>
+        </p:nvSpPr>
+        <p:spPr>
+          <a:xfrm>
+            <a:off x="4572000" y="6345936"/>
+            <a:ext cx="4206240" cy="292608"/>
+          </a:xfrm>
+          <a:prstGeom prst="rect">
+            <a:avLst/>
+          </a:prstGeom>
+          <a:noFill/>
+        </p:spPr>
+        <p:txBody>
+          <a:bodyPr wrap="square" lIns="0" rIns="0" tIns="0" bIns="0">
+            <a:spAutoFit/>
+          </a:bodyPr>
+          <a:lstStyle/>
+          <a:p>
+            <a:pPr algn="ctr"/>
+            <a:r>
+              <a:rPr sz="900" b="0" i="0">
+                <a:solidFill>
+                  <a:srgbClr val="5E6B85"/>
+                </a:solidFill>
+                <a:latin typeface="Courier New"/>
+              </a:rPr>
+              <a:t>PART II - THE TESTS</a:t>
+            </a:r>
+          </a:p>
+        </p:txBody>
+      </p:sp>
+      <p:sp>
+        <p:nvSpPr>
+          <p:cNvPr id="6" name="TextBox 5"/>
+          <p:cNvSpPr txBox="1"/>
+          <p:nvPr/>
+        </p:nvSpPr>
+        <p:spPr>
+          <a:xfrm>
+            <a:off x="8869680" y="6345936"/>
+            <a:ext cx="3017520" cy="292608"/>
+          </a:xfrm>
+          <a:prstGeom prst="rect">
+            <a:avLst/>
+          </a:prstGeom>
+          <a:noFill/>
+        </p:spPr>
+        <p:txBody>
+          <a:bodyPr wrap="square" lIns="0" rIns="0" tIns="0" bIns="0">
+            <a:spAutoFit/>
+          </a:bodyPr>
+          <a:lstStyle/>
+          <a:p>
+            <a:pPr algn="r"/>
+            <a:r>
+              <a:rPr sz="900" b="0" i="0">
+                <a:solidFill>
+                  <a:srgbClr val="5E6B85"/>
+                </a:solidFill>
+                <a:latin typeface="Courier New"/>
+              </a:rPr>
+              <a:t>SHEET 17/18  REV A  2026-10-24</a:t>
             </a:r>
           </a:p>
         </p:txBody>
@@ -10646,7 +12446,7 @@
 </p:sld>
 </file>
 
-<file path=ppt/slides/slide16.xml><?xml version="1.0" encoding="utf-8"?>
+<file path=ppt/slides/slide18.xml><?xml version="1.0" encoding="utf-8"?>
 <p:sld xmlns:a="http://schemas.openxmlformats.org/drawingml/2006/main" xmlns:p="http://schemas.openxmlformats.org/presentationml/2006/main" xmlns:r="http://schemas.openxmlformats.org/officeDocument/2006/relationships">
   <p:cSld>
     <p:spTree>
@@ -10844,7 +12644,7 @@
                 </a:solidFill>
                 <a:latin typeface="Courier New"/>
               </a:rPr>
-              <a:t>SHEET 16/16  REV A  2026-10-24</a:t>
+              <a:t>SHEET 18/18  REV A  2026-10-24</a:t>
             </a:r>
           </a:p>
         </p:txBody>
@@ -11865,7 +13665,7 @@
                 </a:solidFill>
                 <a:latin typeface="Courier New"/>
               </a:rPr>
-              <a:t>SHEET 02/16  REV A  2026-10-24</a:t>
+              <a:t>SHEET 02/18  REV A  2026-10-24</a:t>
             </a:r>
           </a:p>
         </p:txBody>
@@ -12384,7 +14184,7 @@
                 </a:solidFill>
                 <a:latin typeface="Courier New"/>
               </a:rPr>
-              <a:t>SHEET 03/16  REV A  2026-10-24</a:t>
+              <a:t>SHEET 03/18  REV A  2026-10-24</a:t>
             </a:r>
           </a:p>
         </p:txBody>
@@ -12689,7 +14489,7 @@
                 </a:solidFill>
                 <a:latin typeface="Courier New"/>
               </a:rPr>
-              <a:t>SHEET 04/16  REV A  2026-10-24</a:t>
+              <a:t>SHEET 04/18  REV A  2026-10-24</a:t>
             </a:r>
           </a:p>
         </p:txBody>
@@ -13380,7 +15180,7 @@
                 </a:solidFill>
                 <a:latin typeface="Courier New"/>
               </a:rPr>
-              <a:t>SHEET 05/16  REV A  2026-10-24</a:t>
+              <a:t>SHEET 05/18  REV A  2026-10-24</a:t>
             </a:r>
           </a:p>
         </p:txBody>
@@ -14177,7 +15977,7 @@
                 </a:solidFill>
                 <a:latin typeface="Courier New"/>
               </a:rPr>
-              <a:t>SHEET 06/16  REV A  2026-10-24</a:t>
+              <a:t>SHEET 06/18  REV A  2026-10-24</a:t>
             </a:r>
           </a:p>
         </p:txBody>
@@ -14777,7 +16577,7 @@
                 </a:solidFill>
                 <a:latin typeface="Courier New"/>
               </a:rPr>
-              <a:t>SHEET 07/16  REV A  2026-10-24</a:t>
+              <a:t>SHEET 07/18  REV A  2026-10-24</a:t>
             </a:r>
           </a:p>
         </p:txBody>
@@ -15410,7 +17210,7 @@
                 </a:solidFill>
                 <a:latin typeface="Courier New"/>
               </a:rPr>
-              <a:t>SHEET 08/16  REV A  2026-10-24</a:t>
+              <a:t>SHEET 08/18  REV A  2026-10-24</a:t>
             </a:r>
           </a:p>
         </p:txBody>
@@ -16307,7 +18107,7 @@
                 </a:solidFill>
                 <a:latin typeface="Courier New"/>
               </a:rPr>
-              <a:t>SHEET 09/16  REV A  2026-10-24</a:t>
+              <a:t>SHEET 09/18  REV A  2026-10-24</a:t>
             </a:r>
           </a:p>
         </p:txBody>

</xml_diff>